<commit_message>
Update project files: app.py, index.html, docs, screenshots, models, and assets; add .gitignore
</commit_message>
<xml_diff>
--- a/AI_Process_Scheduling_Review1_Polished.pptx
+++ b/AI_Process_Scheduling_Review1_Polished.pptx
@@ -311,7 +311,7 @@
           <a:p>
             <a:fld id="{5BCAD085-E8A6-8845-BD4E-CB4CCA059FC4}" type="datetimeFigureOut">
               <a:rPr lang="en-US" smtClean="0"/>
-              <a:t>10/5/2026</a:t>
+              <a:t>10/8/2026</a:t>
             </a:fld>
             <a:endParaRPr lang="en-US"/>
           </a:p>
@@ -479,7 +479,7 @@
           <a:p>
             <a:fld id="{5BCAD085-E8A6-8845-BD4E-CB4CCA059FC4}" type="datetimeFigureOut">
               <a:rPr lang="en-US" smtClean="0"/>
-              <a:t>10/5/2026</a:t>
+              <a:t>10/8/2026</a:t>
             </a:fld>
             <a:endParaRPr lang="en-US"/>
           </a:p>
@@ -657,7 +657,7 @@
           <a:p>
             <a:fld id="{5BCAD085-E8A6-8845-BD4E-CB4CCA059FC4}" type="datetimeFigureOut">
               <a:rPr lang="en-US" smtClean="0"/>
-              <a:t>10/5/2026</a:t>
+              <a:t>10/8/2026</a:t>
             </a:fld>
             <a:endParaRPr lang="en-US"/>
           </a:p>
@@ -825,7 +825,7 @@
           <a:p>
             <a:fld id="{5BCAD085-E8A6-8845-BD4E-CB4CCA059FC4}" type="datetimeFigureOut">
               <a:rPr lang="en-US" smtClean="0"/>
-              <a:t>10/5/2026</a:t>
+              <a:t>10/8/2026</a:t>
             </a:fld>
             <a:endParaRPr lang="en-US"/>
           </a:p>
@@ -1070,7 +1070,7 @@
           <a:p>
             <a:fld id="{5BCAD085-E8A6-8845-BD4E-CB4CCA059FC4}" type="datetimeFigureOut">
               <a:rPr lang="en-US" smtClean="0"/>
-              <a:t>10/5/2026</a:t>
+              <a:t>10/8/2026</a:t>
             </a:fld>
             <a:endParaRPr lang="en-US"/>
           </a:p>
@@ -1355,7 +1355,7 @@
           <a:p>
             <a:fld id="{5BCAD085-E8A6-8845-BD4E-CB4CCA059FC4}" type="datetimeFigureOut">
               <a:rPr lang="en-US" smtClean="0"/>
-              <a:t>10/5/2026</a:t>
+              <a:t>10/8/2026</a:t>
             </a:fld>
             <a:endParaRPr lang="en-US"/>
           </a:p>
@@ -1774,7 +1774,7 @@
           <a:p>
             <a:fld id="{5BCAD085-E8A6-8845-BD4E-CB4CCA059FC4}" type="datetimeFigureOut">
               <a:rPr lang="en-US" smtClean="0"/>
-              <a:t>10/5/2026</a:t>
+              <a:t>10/8/2026</a:t>
             </a:fld>
             <a:endParaRPr lang="en-US"/>
           </a:p>
@@ -1891,7 +1891,7 @@
           <a:p>
             <a:fld id="{5BCAD085-E8A6-8845-BD4E-CB4CCA059FC4}" type="datetimeFigureOut">
               <a:rPr lang="en-US" smtClean="0"/>
-              <a:t>10/5/2026</a:t>
+              <a:t>10/8/2026</a:t>
             </a:fld>
             <a:endParaRPr lang="en-US"/>
           </a:p>
@@ -1986,7 +1986,7 @@
           <a:p>
             <a:fld id="{5BCAD085-E8A6-8845-BD4E-CB4CCA059FC4}" type="datetimeFigureOut">
               <a:rPr lang="en-US" smtClean="0"/>
-              <a:t>10/5/2026</a:t>
+              <a:t>10/8/2026</a:t>
             </a:fld>
             <a:endParaRPr lang="en-US"/>
           </a:p>
@@ -2261,7 +2261,7 @@
           <a:p>
             <a:fld id="{5BCAD085-E8A6-8845-BD4E-CB4CCA059FC4}" type="datetimeFigureOut">
               <a:rPr lang="en-US" smtClean="0"/>
-              <a:t>10/5/2026</a:t>
+              <a:t>10/8/2026</a:t>
             </a:fld>
             <a:endParaRPr lang="en-US"/>
           </a:p>
@@ -2513,7 +2513,7 @@
           <a:p>
             <a:fld id="{5BCAD085-E8A6-8845-BD4E-CB4CCA059FC4}" type="datetimeFigureOut">
               <a:rPr lang="en-US" smtClean="0"/>
-              <a:t>10/5/2026</a:t>
+              <a:t>10/8/2026</a:t>
             </a:fld>
             <a:endParaRPr lang="en-US"/>
           </a:p>
@@ -2724,7 +2724,7 @@
           <a:p>
             <a:fld id="{5BCAD085-E8A6-8845-BD4E-CB4CCA059FC4}" type="datetimeFigureOut">
               <a:rPr lang="en-US" smtClean="0"/>
-              <a:t>10/5/2026</a:t>
+              <a:t>10/8/2026</a:t>
             </a:fld>
             <a:endParaRPr lang="en-US"/>
           </a:p>
@@ -3385,14 +3385,46 @@
           <a:p>
             <a:pPr algn="ctr"/>
             <a:r>
-              <a:rPr sz="4400" b="1" i="0">
+              <a:rPr sz="4400" b="1" i="0" dirty="0">
                 <a:solidFill>
                   <a:srgbClr val="FFFFFF"/>
                 </a:solidFill>
               </a:rPr>
-              <a:t>AI-Powered Process Scheduling</a:t>
-            </a:r>
-            <a:endParaRPr sz="4400"/>
+              <a:t>AI-</a:t>
+            </a:r>
+            <a:r>
+              <a:rPr lang="en-IN" sz="4400" b="1" i="0" dirty="0">
+                <a:solidFill>
+                  <a:srgbClr val="FFFFFF"/>
+                </a:solidFill>
+              </a:rPr>
+              <a:t>Driven</a:t>
+            </a:r>
+            <a:r>
+              <a:rPr sz="4400" b="1" i="0" dirty="0">
+                <a:solidFill>
+                  <a:srgbClr val="FFFFFF"/>
+                </a:solidFill>
+              </a:rPr>
+              <a:t> Process </a:t>
+            </a:r>
+            <a:r>
+              <a:rPr lang="en-IN" sz="4400" b="1">
+                <a:solidFill>
+                  <a:srgbClr val="FFFFFF"/>
+                </a:solidFill>
+              </a:rPr>
+              <a:t>Scheduling </a:t>
+            </a:r>
+            <a:r>
+              <a:rPr lang="en-IN" sz="4400" b="1" dirty="0">
+                <a:solidFill>
+                  <a:srgbClr val="FFFFFF"/>
+                </a:solidFill>
+              </a:rPr>
+              <a:t>System</a:t>
+            </a:r>
+            <a:endParaRPr sz="4400" dirty="0"/>
           </a:p>
         </p:txBody>
       </p:sp>
@@ -3404,7 +3436,7 @@
         </p:nvSpPr>
         <p:spPr>
           <a:xfrm>
-            <a:off x="457200" y="2441448"/>
+            <a:off x="457200" y="2414016"/>
             <a:ext cx="11274552" cy="457200"/>
           </a:xfrm>
           <a:prstGeom prst="rect">
@@ -13771,14 +13803,14 @@
           <a:p>
             <a:pPr algn="ctr"/>
             <a:r>
-              <a:rPr sz="1200" b="0" i="0">
+              <a:rPr sz="1200" b="0" i="0" dirty="0">
                 <a:solidFill>
                   <a:srgbClr val="CCD6E0"/>
                 </a:solidFill>
               </a:rPr>
               <a:t>Mean Absolute Error</a:t>
             </a:r>
-            <a:endParaRPr sz="1200"/>
+            <a:endParaRPr sz="1200" dirty="0"/>
           </a:p>
         </p:txBody>
       </p:sp>
@@ -14073,14 +14105,14 @@
           <a:p>
             <a:pPr algn="ctr"/>
             <a:r>
-              <a:rPr sz="1200" b="0" i="0">
+              <a:rPr sz="1200" b="0" i="0" dirty="0">
                 <a:solidFill>
                   <a:srgbClr val="CCD6E0"/>
                 </a:solidFill>
               </a:rPr>
               <a:t>Coefficient of Determination</a:t>
             </a:r>
-            <a:endParaRPr sz="1200"/>
+            <a:endParaRPr sz="1200" dirty="0"/>
           </a:p>
         </p:txBody>
       </p:sp>
@@ -14229,7 +14261,23 @@
                   <a:srgbClr val="CCD6E0"/>
                 </a:solidFill>
               </a:rPr>
-              <a:t>Best Performer (100 estimators)</a:t>
+              <a:t>Best Performer (100</a:t>
+            </a:r>
+            <a:r>
+              <a:rPr lang="en-US" sz="1200" b="0" i="0">
+                <a:solidFill>
+                  <a:srgbClr val="CCD6E0"/>
+                </a:solidFill>
+              </a:rPr>
+              <a:t>+ </a:t>
+            </a:r>
+            <a:r>
+              <a:rPr sz="1200" b="0" i="0">
+                <a:solidFill>
+                  <a:srgbClr val="CCD6E0"/>
+                </a:solidFill>
+              </a:rPr>
+              <a:t>estimators)</a:t>
             </a:r>
             <a:endParaRPr sz="1200"/>
           </a:p>

</xml_diff>